<commit_message>
corrected the document in sequence
</commit_message>
<xml_diff>
--- a/class - 2/EDGE_2026_Lecture - 2.pptx
+++ b/class - 2/EDGE_2026_Lecture - 2.pptx
@@ -234,7 +234,7 @@
     <p1510:client id="{0729AEA1-A084-9DB3-FBF8-E120026B02FD}" v="162" dt="2026-04-19T15:56:31.947"/>
     <p1510:client id="{257877EF-8EBE-8E7C-D6D1-3E7943B46C8C}" v="210" dt="2026-04-19T12:12:11.288"/>
     <p1510:client id="{7D9E385C-1CC3-A14C-C1E2-9972EEB1D612}" v="170" dt="2026-04-19T11:47:34.719"/>
-    <p1510:client id="{A1948A0B-0A06-3B83-36BF-CD644A152503}" v="32" dt="2026-04-21T05:20:38.501"/>
+    <p1510:client id="{A1948A0B-0A06-3B83-36BF-CD644A152503}" v="40" dt="2026-04-21T05:35:55.411"/>
   </p1510:revLst>
 </p1510:revInfo>
 </file>
@@ -1188,10 +1188,23 @@
             <a:defRPr cap="all"/>
           </a:pPr>
           <a:r>
-            <a:rPr lang="en-US" b="0" i="0"/>
-            <a:t>Md. Golam Mostofa</a:t>
+            <a:rPr lang="en-US" b="0" i="0" dirty="0">
+              <a:latin typeface="Arial"/>
+              <a:cs typeface="Arial"/>
+            </a:rPr>
+            <a:t>Md. Golam </a:t>
           </a:r>
-          <a:endParaRPr lang="en-US"/>
+          <a:r>
+            <a:rPr lang="en-US" b="0" i="0" dirty="0" err="1">
+              <a:latin typeface="Arial"/>
+              <a:cs typeface="Arial"/>
+            </a:rPr>
+            <a:t>Mostofa</a:t>
+          </a:r>
+          <a:endParaRPr lang="en-US" dirty="0">
+            <a:latin typeface="Arial"/>
+            <a:cs typeface="Arial"/>
+          </a:endParaRPr>
         </a:p>
       </dgm:t>
     </dgm:pt>
@@ -1231,10 +1244,10 @@
             <a:defRPr cap="all"/>
           </a:pPr>
           <a:r>
-            <a:rPr lang="en-US" b="0" i="0"/>
+            <a:rPr lang="en-US" b="0" i="0" cap="none"/>
             <a:t>golam.mostofa@bizzntek.com</a:t>
           </a:r>
-          <a:endParaRPr lang="en-US"/>
+          <a:endParaRPr lang="en-US" cap="none"/>
         </a:p>
       </dgm:t>
     </dgm:pt>
@@ -1306,11 +1319,6 @@
           <a:noFill/>
         </a:ln>
       </dgm:spPr>
-      <dgm:extLst>
-        <a:ext uri="{E40237B7-FDA0-4F09-8148-C483321AD2D9}">
-          <dgm14:cNvPr xmlns:dgm14="http://schemas.microsoft.com/office/drawing/2010/diagram" id="0" name="" descr="Doctor"/>
-        </a:ext>
-      </dgm:extLst>
     </dgm:pt>
     <dgm:pt modelId="{D43D5112-3EE7-46CF-A020-32F2ED542861}" type="pres">
       <dgm:prSet presAssocID="{C34C5B9F-75B1-4FE0-945D-A340F2C560AC}" presName="spaceRect" presStyleCnt="0"/>
@@ -1563,10 +1571,23 @@
             <a:defRPr cap="all"/>
           </a:pPr>
           <a:r>
-            <a:rPr lang="en-US" sz="1600" b="0" i="0" kern="1200"/>
-            <a:t>Md. Golam Mostofa</a:t>
+            <a:rPr lang="en-US" sz="1600" b="0" i="0" kern="1200" dirty="0">
+              <a:latin typeface="Arial"/>
+              <a:cs typeface="Arial"/>
+            </a:rPr>
+            <a:t>Md. Golam </a:t>
           </a:r>
-          <a:endParaRPr lang="en-US" sz="1600" kern="1200"/>
+          <a:r>
+            <a:rPr lang="en-US" sz="1600" b="0" i="0" kern="1200" dirty="0" err="1">
+              <a:latin typeface="Arial"/>
+              <a:cs typeface="Arial"/>
+            </a:rPr>
+            <a:t>Mostofa</a:t>
+          </a:r>
+          <a:endParaRPr lang="en-US" sz="1600" kern="1200" dirty="0">
+            <a:latin typeface="Arial"/>
+            <a:cs typeface="Arial"/>
+          </a:endParaRPr>
         </a:p>
       </dsp:txBody>
       <dsp:txXfrm>
@@ -1715,10 +1736,10 @@
             <a:defRPr cap="all"/>
           </a:pPr>
           <a:r>
-            <a:rPr lang="en-US" sz="1600" b="0" i="0" kern="1200"/>
+            <a:rPr lang="en-US" sz="1600" b="0" i="0" kern="1200" cap="none"/>
             <a:t>golam.mostofa@bizzntek.com</a:t>
           </a:r>
-          <a:endParaRPr lang="en-US" sz="1600" kern="1200"/>
+          <a:endParaRPr lang="en-US" sz="1600" kern="1200" cap="none"/>
         </a:p>
       </dsp:txBody>
       <dsp:txXfrm>
@@ -7238,7 +7259,7 @@
       </p:sp>
       <p:pic>
         <p:nvPicPr>
-          <p:cNvPr id="7" name="Picture 6" descr="A screenshot of a computer program&#10;&#10;AI-generated content may be incorrect.">
+          <p:cNvPr id="7" name="Picture 6" descr="A screenshot of a computer&#10;&#10;AI-generated content may be incorrect.">
             <a:extLst>
               <a:ext uri="{FF2B5EF4-FFF2-40B4-BE49-F238E27FC236}">
                 <a16:creationId xmlns:a16="http://schemas.microsoft.com/office/drawing/2014/main" id="{0AB1E0D4-E95C-FA49-BA06-674638EB9575}"/>
@@ -7258,8 +7279,8 @@
         </p:blipFill>
         <p:spPr>
           <a:xfrm>
-            <a:off x="5657850" y="2276630"/>
-            <a:ext cx="5695950" cy="2076139"/>
+            <a:off x="5657850" y="1516327"/>
+            <a:ext cx="5695950" cy="2371366"/>
           </a:xfrm>
           <a:prstGeom prst="rect">
             <a:avLst/>

</xml_diff>